<commit_message>
docs(proposal): update presentation slides and add exported pdf
</commit_message>
<xml_diff>
--- a/reports/proposal/AI2002_Group09_Research_Proposal_Presentation.pptx
+++ b/reports/proposal/AI2002_Group09_Research_Proposal_Presentation.pptx
@@ -3589,7 +3589,7 @@
         <p:spPr>
           <a:xfrm>
             <a:off x="731520" y="1143000"/>
-            <a:ext cx="7680960" cy="1097280"/>
+            <a:ext cx="7680960" cy="800219"/>
           </a:xfrm>
           <a:prstGeom prst="rect">
             <a:avLst/>
@@ -3603,9 +3603,6 @@
           <a:lstStyle/>
           <a:p>
             <a:pPr>
-              <a:lnSpc>
-                <a:spcPct val="200000"/>
-              </a:lnSpc>
               <a:spcAft>
                 <a:spcPts val="800"/>
               </a:spcAft>
@@ -3617,10 +3614,14 @@
               </a:defRPr>
             </a:pPr>
             <a:r>
+              <a:rPr dirty="0"/>
               <a:t>Failure-Aware &amp; Resource-Adaptive</a:t>
             </a:r>
-            <a:br/>
-            <a:r>
+            <a:br>
+              <a:rPr lang="en-US" dirty="0"/>
+            </a:br>
+            <a:r>
+              <a:rPr dirty="0"/>
               <a:t>2D Aerial Mosaicking for UAV Video</a:t>
             </a:r>
           </a:p>
@@ -3660,8 +3661,138 @@
               </a:defRPr>
             </a:pPr>
             <a:r>
-              <a:t>Ghép ảnh 2D từ video UAV: Tự nhận biết rủi ro, phân luồng tài nguyên và khống chế trôi dạt</a:t>
-            </a:r>
+              <a:rPr dirty="0" err="1"/>
+              <a:t>Ghép</a:t>
+            </a:r>
+            <a:r>
+              <a:rPr dirty="0"/>
+              <a:t> </a:t>
+            </a:r>
+            <a:r>
+              <a:rPr dirty="0" err="1"/>
+              <a:t>ảnh</a:t>
+            </a:r>
+            <a:r>
+              <a:rPr dirty="0"/>
+              <a:t> 2D </a:t>
+            </a:r>
+            <a:r>
+              <a:rPr dirty="0" err="1"/>
+              <a:t>từ</a:t>
+            </a:r>
+            <a:r>
+              <a:rPr dirty="0"/>
+              <a:t> video UAV: </a:t>
+            </a:r>
+            <a:r>
+              <a:rPr dirty="0" err="1"/>
+              <a:t>Tự</a:t>
+            </a:r>
+            <a:r>
+              <a:rPr dirty="0"/>
+              <a:t> </a:t>
+            </a:r>
+            <a:r>
+              <a:rPr dirty="0" err="1"/>
+              <a:t>nhận</a:t>
+            </a:r>
+            <a:r>
+              <a:rPr dirty="0"/>
+              <a:t> </a:t>
+            </a:r>
+            <a:r>
+              <a:rPr dirty="0" err="1"/>
+              <a:t>biết</a:t>
+            </a:r>
+            <a:r>
+              <a:rPr dirty="0"/>
+              <a:t> </a:t>
+            </a:r>
+            <a:r>
+              <a:rPr dirty="0" err="1"/>
+              <a:t>rủi</a:t>
+            </a:r>
+            <a:r>
+              <a:rPr dirty="0"/>
+              <a:t> </a:t>
+            </a:r>
+            <a:r>
+              <a:rPr dirty="0" err="1"/>
+              <a:t>ro</a:t>
+            </a:r>
+            <a:r>
+              <a:rPr dirty="0"/>
+              <a:t>, </a:t>
+            </a:r>
+            <a:r>
+              <a:rPr dirty="0" err="1"/>
+              <a:t>phân</a:t>
+            </a:r>
+            <a:r>
+              <a:rPr dirty="0"/>
+              <a:t> </a:t>
+            </a:r>
+            <a:r>
+              <a:rPr dirty="0" err="1"/>
+              <a:t>luồng</a:t>
+            </a:r>
+            <a:r>
+              <a:rPr dirty="0"/>
+              <a:t> </a:t>
+            </a:r>
+            <a:r>
+              <a:rPr dirty="0" err="1"/>
+              <a:t>tài</a:t>
+            </a:r>
+            <a:r>
+              <a:rPr dirty="0"/>
+              <a:t> </a:t>
+            </a:r>
+            <a:r>
+              <a:rPr dirty="0" err="1"/>
+              <a:t>nguyên</a:t>
+            </a:r>
+            <a:r>
+              <a:rPr dirty="0"/>
+              <a:t> </a:t>
+            </a:r>
+            <a:r>
+              <a:rPr dirty="0" err="1"/>
+              <a:t>và</a:t>
+            </a:r>
+            <a:r>
+              <a:rPr dirty="0"/>
+              <a:t> </a:t>
+            </a:r>
+            <a:r>
+              <a:rPr dirty="0" err="1"/>
+              <a:t>khống</a:t>
+            </a:r>
+            <a:r>
+              <a:rPr dirty="0"/>
+              <a:t> </a:t>
+            </a:r>
+            <a:r>
+              <a:rPr dirty="0" err="1"/>
+              <a:t>chế</a:t>
+            </a:r>
+            <a:r>
+              <a:rPr dirty="0"/>
+              <a:t> </a:t>
+            </a:r>
+            <a:r>
+              <a:rPr dirty="0" err="1"/>
+              <a:t>trôi</a:t>
+            </a:r>
+            <a:r>
+              <a:rPr dirty="0"/>
+              <a:t> </a:t>
+            </a:r>
+            <a:r>
+              <a:rPr dirty="0" err="1"/>
+              <a:t>dạt</a:t>
+            </a:r>
+            <a:endParaRPr dirty="0"/>
           </a:p>
         </p:txBody>
       </p:sp>
@@ -4199,7 +4330,7 @@
         </p:nvSpPr>
         <p:spPr>
           <a:xfrm>
-            <a:off x="731520" y="1115568"/>
+            <a:off x="731520" y="1210158"/>
             <a:ext cx="7680960" cy="12700"/>
           </a:xfrm>
           <a:prstGeom prst="rect">
@@ -5521,7 +5652,7 @@
         </p:nvSpPr>
         <p:spPr>
           <a:xfrm>
-            <a:off x="731520" y="1115568"/>
+            <a:off x="731520" y="1231680"/>
             <a:ext cx="7680960" cy="12700"/>
           </a:xfrm>
           <a:prstGeom prst="rect">
@@ -5613,54 +5744,6 @@
             <a:r>
               <a:t>Video UAV tuần tự ngoài thực địa</a:t>
             </a:r>
-          </a:p>
-        </p:txBody>
-      </p:sp>
-      <p:sp>
-        <p:nvSpPr>
-          <p:cNvPr id="5" name="Rectangle 4"/>
-          <p:cNvSpPr/>
-          <p:nvPr/>
-        </p:nvSpPr>
-        <p:spPr>
-          <a:xfrm>
-            <a:off x="731520" y="1874519"/>
-            <a:ext cx="3566160" cy="12700"/>
-          </a:xfrm>
-          <a:prstGeom prst="rect">
-            <a:avLst/>
-          </a:prstGeom>
-          <a:solidFill>
-            <a:srgbClr val="27272A"/>
-          </a:solidFill>
-          <a:ln>
-            <a:noFill/>
-          </a:ln>
-        </p:spPr>
-        <p:style>
-          <a:lnRef idx="1">
-            <a:schemeClr val="accent1"/>
-          </a:lnRef>
-          <a:fillRef idx="3">
-            <a:schemeClr val="accent1"/>
-          </a:fillRef>
-          <a:effectRef idx="2">
-            <a:schemeClr val="accent1"/>
-          </a:effectRef>
-          <a:fontRef idx="minor">
-            <a:schemeClr val="lt1"/>
-          </a:fontRef>
-        </p:style>
-        <p:txBody>
-          <a:bodyPr rtlCol="0" anchor="ctr"/>
-          <a:lstStyle/>
-          <a:p>
-            <a:pPr algn="ctr">
-              <a:lnSpc>
-                <a:spcPct val="200000"/>
-              </a:lnSpc>
-            </a:pPr>
-            <a:endParaRPr/>
           </a:p>
         </p:txBody>
       </p:sp>
@@ -5939,54 +6022,6 @@
             <a:r>
               <a:t>Bản đồ hiện trạng 2D &amp; Metadata</a:t>
             </a:r>
-          </a:p>
-        </p:txBody>
-      </p:sp>
-      <p:sp>
-        <p:nvSpPr>
-          <p:cNvPr id="9" name="Rectangle 8"/>
-          <p:cNvSpPr/>
-          <p:nvPr/>
-        </p:nvSpPr>
-        <p:spPr>
-          <a:xfrm>
-            <a:off x="4754880" y="1874519"/>
-            <a:ext cx="3657600" cy="12700"/>
-          </a:xfrm>
-          <a:prstGeom prst="rect">
-            <a:avLst/>
-          </a:prstGeom>
-          <a:solidFill>
-            <a:srgbClr val="27272A"/>
-          </a:solidFill>
-          <a:ln>
-            <a:noFill/>
-          </a:ln>
-        </p:spPr>
-        <p:style>
-          <a:lnRef idx="1">
-            <a:schemeClr val="accent1"/>
-          </a:lnRef>
-          <a:fillRef idx="3">
-            <a:schemeClr val="accent1"/>
-          </a:fillRef>
-          <a:effectRef idx="2">
-            <a:schemeClr val="accent1"/>
-          </a:effectRef>
-          <a:fontRef idx="minor">
-            <a:schemeClr val="lt1"/>
-          </a:fontRef>
-        </p:style>
-        <p:txBody>
-          <a:bodyPr rtlCol="0" anchor="ctr"/>
-          <a:lstStyle/>
-          <a:p>
-            <a:pPr algn="ctr">
-              <a:lnSpc>
-                <a:spcPct val="200000"/>
-              </a:lnSpc>
-            </a:pPr>
-            <a:endParaRPr/>
           </a:p>
         </p:txBody>
       </p:sp>
@@ -6762,7 +6797,7 @@
         </p:nvSpPr>
         <p:spPr>
           <a:xfrm>
-            <a:off x="731520" y="1115568"/>
+            <a:off x="731520" y="1186511"/>
             <a:ext cx="7680960" cy="12700"/>
           </a:xfrm>
           <a:prstGeom prst="rect">
@@ -6873,7 +6908,7 @@
         </p:blipFill>
         <p:spPr>
           <a:xfrm>
-            <a:off x="731520" y="1783080"/>
+            <a:off x="731520" y="1892811"/>
             <a:ext cx="3657600" cy="1508760"/>
           </a:xfrm>
           <a:prstGeom prst="rect">
@@ -6996,7 +7031,7 @@
         </p:nvSpPr>
         <p:spPr>
           <a:xfrm>
-            <a:off x="4572000" y="1234440"/>
+            <a:off x="4572000" y="1265970"/>
             <a:ext cx="9144" cy="3429000"/>
           </a:xfrm>
           <a:prstGeom prst="rect">
@@ -7107,7 +7142,7 @@
         </p:blipFill>
         <p:spPr>
           <a:xfrm>
-            <a:off x="4754880" y="1783080"/>
+            <a:off x="4754880" y="1892811"/>
             <a:ext cx="3657600" cy="1508760"/>
           </a:xfrm>
           <a:prstGeom prst="rect">
@@ -7321,7 +7356,7 @@
         </p:nvSpPr>
         <p:spPr>
           <a:xfrm>
-            <a:off x="731520" y="1115568"/>
+            <a:off x="731520" y="1198334"/>
             <a:ext cx="7680960" cy="12700"/>
           </a:xfrm>
           <a:prstGeom prst="rect">
@@ -8105,7 +8140,7 @@
         </p:nvSpPr>
         <p:spPr>
           <a:xfrm>
-            <a:off x="731520" y="1115568"/>
+            <a:off x="731520" y="1202276"/>
             <a:ext cx="7680960" cy="12700"/>
           </a:xfrm>
           <a:prstGeom prst="rect">
@@ -8958,7 +8993,7 @@
         </p:nvSpPr>
         <p:spPr>
           <a:xfrm>
-            <a:off x="4160520" y="2880360"/>
+            <a:off x="4340880" y="2761488"/>
             <a:ext cx="822960" cy="384048"/>
           </a:xfrm>
           <a:prstGeom prst="rect">
@@ -8978,7 +9013,7 @@
               </a:lnSpc>
             </a:pPr>
             <a:r>
-              <a:rPr sz="1300" b="1">
+              <a:rPr sz="1300" b="1" dirty="0">
                 <a:solidFill>
                   <a:srgbClr val="38BDF8"/>
                 </a:solidFill>
@@ -8994,13 +9029,40 @@
               </a:lnSpc>
             </a:pPr>
             <a:r>
-              <a:rPr sz="700" b="1">
+              <a:rPr sz="700" b="1" dirty="0" err="1">
                 <a:solidFill>
                   <a:srgbClr val="38BDF8"/>
                 </a:solidFill>
                 <a:latin typeface="Segoe UI"/>
               </a:rPr>
-              <a:t>Rủi ro (10%)</a:t>
+              <a:t>Rủi</a:t>
+            </a:r>
+            <a:r>
+              <a:rPr sz="700" b="1" dirty="0">
+                <a:solidFill>
+                  <a:srgbClr val="38BDF8"/>
+                </a:solidFill>
+                <a:latin typeface="Segoe UI"/>
+              </a:rPr>
+              <a:t> </a:t>
+            </a:r>
+            <a:r>
+              <a:rPr sz="700" b="1" dirty="0" err="1">
+                <a:solidFill>
+                  <a:srgbClr val="38BDF8"/>
+                </a:solidFill>
+                <a:latin typeface="Segoe UI"/>
+              </a:rPr>
+              <a:t>ro</a:t>
+            </a:r>
+            <a:r>
+              <a:rPr sz="700" b="1" dirty="0">
+                <a:solidFill>
+                  <a:srgbClr val="38BDF8"/>
+                </a:solidFill>
+                <a:latin typeface="Segoe UI"/>
+              </a:rPr>
+              <a:t> (10%)</a:t>
             </a:r>
           </a:p>
         </p:txBody>
@@ -9013,7 +9075,7 @@
         </p:nvSpPr>
         <p:spPr>
           <a:xfrm>
-            <a:off x="2514600" y="3291840"/>
+            <a:off x="2984255" y="3424428"/>
             <a:ext cx="2011680" cy="1508760"/>
           </a:xfrm>
           <a:prstGeom prst="rect">
@@ -9063,7 +9125,7 @@
         </p:nvSpPr>
         <p:spPr>
           <a:xfrm>
-            <a:off x="2624328" y="3383280"/>
+            <a:off x="3093983" y="3515868"/>
             <a:ext cx="1792224" cy="1325880"/>
           </a:xfrm>
           <a:prstGeom prst="rect">
@@ -9092,6 +9154,7 @@
               </a:defRPr>
             </a:pPr>
             <a:r>
+              <a:rPr dirty="0"/>
               <a:t>TẦNG 2: HỌC SÂU (GPU) — RQ2</a:t>
             </a:r>
           </a:p>
@@ -9111,8 +9174,14 @@
               </a:defRPr>
             </a:pPr>
             <a:r>
-              <a:t>SIFT + LightGlue</a:t>
-            </a:r>
+              <a:rPr dirty="0"/>
+              <a:t>SIFT + </a:t>
+            </a:r>
+            <a:r>
+              <a:rPr dirty="0" err="1"/>
+              <a:t>LightGlue</a:t>
+            </a:r>
+            <a:endParaRPr dirty="0"/>
           </a:p>
           <a:p>
             <a:pPr>
@@ -9130,8 +9199,54 @@
               </a:defRPr>
             </a:pPr>
             <a:r>
-              <a:t>• Kích hoạt khi rủi ro đỏ</a:t>
-            </a:r>
+              <a:rPr dirty="0"/>
+              <a:t>• </a:t>
+            </a:r>
+            <a:r>
+              <a:rPr dirty="0" err="1"/>
+              <a:t>Kích</a:t>
+            </a:r>
+            <a:r>
+              <a:rPr dirty="0"/>
+              <a:t> </a:t>
+            </a:r>
+            <a:r>
+              <a:rPr dirty="0" err="1"/>
+              <a:t>hoạt</a:t>
+            </a:r>
+            <a:r>
+              <a:rPr dirty="0"/>
+              <a:t> </a:t>
+            </a:r>
+            <a:r>
+              <a:rPr dirty="0" err="1"/>
+              <a:t>khi</a:t>
+            </a:r>
+            <a:r>
+              <a:rPr dirty="0"/>
+              <a:t> </a:t>
+            </a:r>
+            <a:r>
+              <a:rPr dirty="0" err="1"/>
+              <a:t>rủi</a:t>
+            </a:r>
+            <a:r>
+              <a:rPr dirty="0"/>
+              <a:t> </a:t>
+            </a:r>
+            <a:r>
+              <a:rPr dirty="0" err="1"/>
+              <a:t>ro</a:t>
+            </a:r>
+            <a:r>
+              <a:rPr dirty="0"/>
+              <a:t> </a:t>
+            </a:r>
+            <a:r>
+              <a:rPr dirty="0" err="1"/>
+              <a:t>đỏ</a:t>
+            </a:r>
+            <a:endParaRPr dirty="0"/>
           </a:p>
           <a:p>
             <a:pPr>
@@ -9149,7 +9264,24 @@
               </a:defRPr>
             </a:pPr>
             <a:r>
-              <a:t>• Giảm 85% tải so GPU full</a:t>
+              <a:rPr dirty="0"/>
+              <a:t>• </a:t>
+            </a:r>
+            <a:r>
+              <a:rPr dirty="0" err="1"/>
+              <a:t>Giảm</a:t>
+            </a:r>
+            <a:r>
+              <a:rPr dirty="0"/>
+              <a:t> 85% </a:t>
+            </a:r>
+            <a:r>
+              <a:rPr dirty="0" err="1"/>
+              <a:t>tải</a:t>
+            </a:r>
+            <a:r>
+              <a:rPr dirty="0"/>
+              <a:t> so GPU full</a:t>
             </a:r>
           </a:p>
           <a:p>
@@ -9168,8 +9300,54 @@
               </a:defRPr>
             </a:pPr>
             <a:r>
-              <a:t>• Vượt trội góc xoay &amp; lặp vân</a:t>
-            </a:r>
+              <a:rPr dirty="0"/>
+              <a:t>• </a:t>
+            </a:r>
+            <a:r>
+              <a:rPr dirty="0" err="1"/>
+              <a:t>Vượt</a:t>
+            </a:r>
+            <a:r>
+              <a:rPr dirty="0"/>
+              <a:t> </a:t>
+            </a:r>
+            <a:r>
+              <a:rPr dirty="0" err="1"/>
+              <a:t>trội</a:t>
+            </a:r>
+            <a:r>
+              <a:rPr dirty="0"/>
+              <a:t> </a:t>
+            </a:r>
+            <a:r>
+              <a:rPr dirty="0" err="1"/>
+              <a:t>góc</a:t>
+            </a:r>
+            <a:r>
+              <a:rPr dirty="0"/>
+              <a:t> </a:t>
+            </a:r>
+            <a:r>
+              <a:rPr dirty="0" err="1"/>
+              <a:t>xoay</a:t>
+            </a:r>
+            <a:r>
+              <a:rPr dirty="0"/>
+              <a:t> &amp; </a:t>
+            </a:r>
+            <a:r>
+              <a:rPr dirty="0" err="1"/>
+              <a:t>lặp</a:t>
+            </a:r>
+            <a:r>
+              <a:rPr dirty="0"/>
+              <a:t> </a:t>
+            </a:r>
+            <a:r>
+              <a:rPr dirty="0" err="1"/>
+              <a:t>vân</a:t>
+            </a:r>
+            <a:endParaRPr dirty="0"/>
           </a:p>
         </p:txBody>
       </p:sp>
@@ -9181,7 +9359,7 @@
         </p:nvSpPr>
         <p:spPr>
           <a:xfrm>
-            <a:off x="4553712" y="3840480"/>
+            <a:off x="5069715" y="4019015"/>
             <a:ext cx="320040" cy="365760"/>
           </a:xfrm>
           <a:prstGeom prst="rect">
@@ -9201,7 +9379,7 @@
               </a:lnSpc>
             </a:pPr>
             <a:r>
-              <a:rPr sz="1300" b="1">
+              <a:rPr sz="1300" b="1" dirty="0">
                 <a:solidFill>
                   <a:srgbClr val="34D399"/>
                 </a:solidFill>
@@ -9220,7 +9398,7 @@
         </p:nvSpPr>
         <p:spPr>
           <a:xfrm>
-            <a:off x="4892040" y="3291840"/>
+            <a:off x="5463536" y="3291840"/>
             <a:ext cx="1828800" cy="1508760"/>
           </a:xfrm>
           <a:prstGeom prst="rect">
@@ -9270,7 +9448,7 @@
         </p:nvSpPr>
         <p:spPr>
           <a:xfrm>
-            <a:off x="5001768" y="3383280"/>
+            <a:off x="5573264" y="3383280"/>
             <a:ext cx="1609344" cy="1325880"/>
           </a:xfrm>
           <a:prstGeom prst="rect">
@@ -9388,7 +9566,7 @@
         </p:nvSpPr>
         <p:spPr>
           <a:xfrm>
-            <a:off x="6748272" y="3566160"/>
+            <a:off x="7319768" y="3566160"/>
             <a:ext cx="548640" cy="502920"/>
           </a:xfrm>
           <a:prstGeom prst="rect">
@@ -9476,7 +9654,7 @@
         </p:nvSpPr>
         <p:spPr>
           <a:xfrm>
-            <a:off x="731520" y="384048"/>
+            <a:off x="731520" y="238908"/>
             <a:ext cx="7680960" cy="658368"/>
           </a:xfrm>
           <a:prstGeom prst="rect">
@@ -9505,6 +9683,7 @@
               </a:defRPr>
             </a:pPr>
             <a:r>
+              <a:rPr dirty="0"/>
               <a:t>06 / ĐỀ XUẤT ĐÓNG GÓP CỦA NHÓM</a:t>
             </a:r>
           </a:p>
@@ -9521,8 +9700,102 @@
               </a:defRPr>
             </a:pPr>
             <a:r>
-              <a:t>3 Đóng góp cốt lõi cho bài toán &amp; Lộ trình thực hiện 6 tuần</a:t>
-            </a:r>
+              <a:rPr dirty="0"/>
+              <a:t>3 </a:t>
+            </a:r>
+            <a:r>
+              <a:rPr dirty="0" err="1"/>
+              <a:t>Đóng</a:t>
+            </a:r>
+            <a:r>
+              <a:rPr dirty="0"/>
+              <a:t> </a:t>
+            </a:r>
+            <a:r>
+              <a:rPr dirty="0" err="1"/>
+              <a:t>góp</a:t>
+            </a:r>
+            <a:r>
+              <a:rPr dirty="0"/>
+              <a:t> </a:t>
+            </a:r>
+            <a:r>
+              <a:rPr dirty="0" err="1"/>
+              <a:t>cốt</a:t>
+            </a:r>
+            <a:r>
+              <a:rPr dirty="0"/>
+              <a:t> </a:t>
+            </a:r>
+            <a:r>
+              <a:rPr dirty="0" err="1"/>
+              <a:t>lõi</a:t>
+            </a:r>
+            <a:r>
+              <a:rPr dirty="0"/>
+              <a:t> </a:t>
+            </a:r>
+            <a:r>
+              <a:rPr dirty="0" err="1"/>
+              <a:t>cho</a:t>
+            </a:r>
+            <a:r>
+              <a:rPr dirty="0"/>
+              <a:t> </a:t>
+            </a:r>
+            <a:r>
+              <a:rPr dirty="0" err="1"/>
+              <a:t>bài</a:t>
+            </a:r>
+            <a:r>
+              <a:rPr dirty="0"/>
+              <a:t> </a:t>
+            </a:r>
+            <a:r>
+              <a:rPr dirty="0" err="1"/>
+              <a:t>toán</a:t>
+            </a:r>
+            <a:r>
+              <a:rPr dirty="0"/>
+              <a:t> &amp; </a:t>
+            </a:r>
+            <a:r>
+              <a:rPr dirty="0" err="1"/>
+              <a:t>Lộ</a:t>
+            </a:r>
+            <a:r>
+              <a:rPr dirty="0"/>
+              <a:t> </a:t>
+            </a:r>
+            <a:r>
+              <a:rPr dirty="0" err="1"/>
+              <a:t>trình</a:t>
+            </a:r>
+            <a:r>
+              <a:rPr dirty="0"/>
+              <a:t> </a:t>
+            </a:r>
+            <a:r>
+              <a:rPr dirty="0" err="1"/>
+              <a:t>thực</a:t>
+            </a:r>
+            <a:r>
+              <a:rPr dirty="0"/>
+              <a:t> </a:t>
+            </a:r>
+            <a:r>
+              <a:rPr dirty="0" err="1"/>
+              <a:t>hiện</a:t>
+            </a:r>
+            <a:r>
+              <a:rPr dirty="0"/>
+              <a:t> 6 </a:t>
+            </a:r>
+            <a:r>
+              <a:rPr dirty="0" err="1"/>
+              <a:t>tuần</a:t>
+            </a:r>
+            <a:endParaRPr dirty="0"/>
           </a:p>
         </p:txBody>
       </p:sp>
@@ -9534,7 +9807,7 @@
         </p:nvSpPr>
         <p:spPr>
           <a:xfrm>
-            <a:off x="731520" y="1115568"/>
+            <a:off x="731520" y="1093797"/>
             <a:ext cx="7680960" cy="12700"/>
           </a:xfrm>
           <a:prstGeom prst="rect">
@@ -9582,7 +9855,7 @@
         </p:nvSpPr>
         <p:spPr>
           <a:xfrm>
-            <a:off x="731520" y="1325880"/>
+            <a:off x="731520" y="1187997"/>
             <a:ext cx="3657600" cy="411480"/>
           </a:xfrm>
           <a:prstGeom prst="rect">
@@ -9631,61 +9904,13 @@
       </p:sp>
       <p:sp>
         <p:nvSpPr>
-          <p:cNvPr id="5" name="Rectangle 4"/>
-          <p:cNvSpPr/>
-          <p:nvPr/>
-        </p:nvSpPr>
-        <p:spPr>
-          <a:xfrm>
-            <a:off x="731520" y="1874519"/>
-            <a:ext cx="3566160" cy="12700"/>
-          </a:xfrm>
-          <a:prstGeom prst="rect">
-            <a:avLst/>
-          </a:prstGeom>
-          <a:solidFill>
-            <a:srgbClr val="27272A"/>
-          </a:solidFill>
-          <a:ln>
-            <a:noFill/>
-          </a:ln>
-        </p:spPr>
-        <p:style>
-          <a:lnRef idx="1">
-            <a:schemeClr val="accent1"/>
-          </a:lnRef>
-          <a:fillRef idx="3">
-            <a:schemeClr val="accent1"/>
-          </a:fillRef>
-          <a:effectRef idx="2">
-            <a:schemeClr val="accent1"/>
-          </a:effectRef>
-          <a:fontRef idx="minor">
-            <a:schemeClr val="lt1"/>
-          </a:fontRef>
-        </p:style>
-        <p:txBody>
-          <a:bodyPr rtlCol="0" anchor="ctr"/>
-          <a:lstStyle/>
-          <a:p>
-            <a:pPr algn="ctr">
-              <a:lnSpc>
-                <a:spcPct val="200000"/>
-              </a:lnSpc>
-            </a:pPr>
-            <a:endParaRPr/>
-          </a:p>
-        </p:txBody>
-      </p:sp>
-      <p:sp>
-        <p:nvSpPr>
           <p:cNvPr id="6" name="TextBox 5"/>
           <p:cNvSpPr txBox="1"/>
           <p:nvPr/>
         </p:nvSpPr>
         <p:spPr>
           <a:xfrm>
-            <a:off x="731520" y="2011680"/>
+            <a:off x="731520" y="1873797"/>
             <a:ext cx="3566160" cy="2743200"/>
           </a:xfrm>
           <a:prstGeom prst="rect">
@@ -9822,7 +10047,7 @@
         </p:nvSpPr>
         <p:spPr>
           <a:xfrm>
-            <a:off x="4526280" y="1325880"/>
+            <a:off x="4526280" y="1187997"/>
             <a:ext cx="9144" cy="3302000"/>
           </a:xfrm>
           <a:prstGeom prst="rect">
@@ -9870,7 +10095,7 @@
         </p:nvSpPr>
         <p:spPr>
           <a:xfrm>
-            <a:off x="4754880" y="1325880"/>
+            <a:off x="4754880" y="1187997"/>
             <a:ext cx="3657600" cy="411480"/>
           </a:xfrm>
           <a:prstGeom prst="rect">
@@ -9919,61 +10144,13 @@
       </p:sp>
       <p:sp>
         <p:nvSpPr>
-          <p:cNvPr id="9" name="Rectangle 8"/>
-          <p:cNvSpPr/>
-          <p:nvPr/>
-        </p:nvSpPr>
-        <p:spPr>
-          <a:xfrm>
-            <a:off x="4754880" y="1874519"/>
-            <a:ext cx="3657600" cy="12700"/>
-          </a:xfrm>
-          <a:prstGeom prst="rect">
-            <a:avLst/>
-          </a:prstGeom>
-          <a:solidFill>
-            <a:srgbClr val="27272A"/>
-          </a:solidFill>
-          <a:ln>
-            <a:noFill/>
-          </a:ln>
-        </p:spPr>
-        <p:style>
-          <a:lnRef idx="1">
-            <a:schemeClr val="accent1"/>
-          </a:lnRef>
-          <a:fillRef idx="3">
-            <a:schemeClr val="accent1"/>
-          </a:fillRef>
-          <a:effectRef idx="2">
-            <a:schemeClr val="accent1"/>
-          </a:effectRef>
-          <a:fontRef idx="minor">
-            <a:schemeClr val="lt1"/>
-          </a:fontRef>
-        </p:style>
-        <p:txBody>
-          <a:bodyPr rtlCol="0" anchor="ctr"/>
-          <a:lstStyle/>
-          <a:p>
-            <a:pPr algn="ctr">
-              <a:lnSpc>
-                <a:spcPct val="200000"/>
-              </a:lnSpc>
-            </a:pPr>
-            <a:endParaRPr/>
-          </a:p>
-        </p:txBody>
-      </p:sp>
-      <p:sp>
-        <p:nvSpPr>
           <p:cNvPr id="10" name="TextBox 9"/>
           <p:cNvSpPr txBox="1"/>
           <p:nvPr/>
         </p:nvSpPr>
         <p:spPr>
           <a:xfrm>
-            <a:off x="4754880" y="2011680"/>
+            <a:off x="4754880" y="1873797"/>
             <a:ext cx="3657600" cy="2743200"/>
           </a:xfrm>
           <a:prstGeom prst="rect">
@@ -10322,7 +10499,7 @@
         </p:nvSpPr>
         <p:spPr>
           <a:xfrm>
-            <a:off x="731520" y="1115568"/>
+            <a:off x="731520" y="1214101"/>
             <a:ext cx="7680960" cy="12700"/>
           </a:xfrm>
           <a:prstGeom prst="rect">
@@ -10399,8 +10576,54 @@
               </a:defRPr>
             </a:pPr>
             <a:r>
-              <a:t>01  Tính thời sự &amp; thực tiễn cao</a:t>
-            </a:r>
+              <a:rPr dirty="0"/>
+              <a:t>01  </a:t>
+            </a:r>
+            <a:r>
+              <a:rPr dirty="0" err="1"/>
+              <a:t>Tính</a:t>
+            </a:r>
+            <a:r>
+              <a:rPr dirty="0"/>
+              <a:t> </a:t>
+            </a:r>
+            <a:r>
+              <a:rPr dirty="0" err="1"/>
+              <a:t>thời</a:t>
+            </a:r>
+            <a:r>
+              <a:rPr dirty="0"/>
+              <a:t> </a:t>
+            </a:r>
+            <a:r>
+              <a:rPr dirty="0" err="1"/>
+              <a:t>sự</a:t>
+            </a:r>
+            <a:r>
+              <a:rPr dirty="0"/>
+              <a:t> &amp; </a:t>
+            </a:r>
+            <a:r>
+              <a:rPr dirty="0" err="1"/>
+              <a:t>thực</a:t>
+            </a:r>
+            <a:r>
+              <a:rPr dirty="0"/>
+              <a:t> </a:t>
+            </a:r>
+            <a:r>
+              <a:rPr dirty="0" err="1"/>
+              <a:t>tiễn</a:t>
+            </a:r>
+            <a:r>
+              <a:rPr dirty="0"/>
+              <a:t> </a:t>
+            </a:r>
+            <a:r>
+              <a:rPr dirty="0" err="1"/>
+              <a:t>cao</a:t>
+            </a:r>
+            <a:endParaRPr dirty="0"/>
           </a:p>
           <a:p>
             <a:pPr>
@@ -10418,7 +10641,276 @@
               </a:defRPr>
             </a:pPr>
             <a:r>
-              <a:t>Tạo bản đồ ảnh 2D hiện trường nhanh phục vụ cứu hộ thiên tai, bão lũ và nông nghiệp; khắc phục triệt để mất dấu và trôi dạt tích lũy mà không ép buộc GPS RTK đắt tiền.</a:t>
+              <a:rPr dirty="0" err="1"/>
+              <a:t>Tạo</a:t>
+            </a:r>
+            <a:r>
+              <a:rPr dirty="0"/>
+              <a:t> </a:t>
+            </a:r>
+            <a:r>
+              <a:rPr dirty="0" err="1"/>
+              <a:t>bản</a:t>
+            </a:r>
+            <a:r>
+              <a:rPr dirty="0"/>
+              <a:t> </a:t>
+            </a:r>
+            <a:r>
+              <a:rPr dirty="0" err="1"/>
+              <a:t>đồ</a:t>
+            </a:r>
+            <a:r>
+              <a:rPr dirty="0"/>
+              <a:t> </a:t>
+            </a:r>
+            <a:r>
+              <a:rPr dirty="0" err="1"/>
+              <a:t>ảnh</a:t>
+            </a:r>
+            <a:r>
+              <a:rPr dirty="0"/>
+              <a:t> 2D </a:t>
+            </a:r>
+            <a:r>
+              <a:rPr dirty="0" err="1"/>
+              <a:t>hiện</a:t>
+            </a:r>
+            <a:r>
+              <a:rPr dirty="0"/>
+              <a:t> </a:t>
+            </a:r>
+            <a:r>
+              <a:rPr dirty="0" err="1"/>
+              <a:t>trường</a:t>
+            </a:r>
+            <a:r>
+              <a:rPr dirty="0"/>
+              <a:t> </a:t>
+            </a:r>
+            <a:r>
+              <a:rPr dirty="0" err="1"/>
+              <a:t>nhanh</a:t>
+            </a:r>
+            <a:r>
+              <a:rPr dirty="0"/>
+              <a:t> </a:t>
+            </a:r>
+            <a:r>
+              <a:rPr dirty="0" err="1"/>
+              <a:t>phục</a:t>
+            </a:r>
+            <a:r>
+              <a:rPr dirty="0"/>
+              <a:t> </a:t>
+            </a:r>
+            <a:r>
+              <a:rPr dirty="0" err="1"/>
+              <a:t>vụ</a:t>
+            </a:r>
+            <a:r>
+              <a:rPr dirty="0"/>
+              <a:t> </a:t>
+            </a:r>
+            <a:r>
+              <a:rPr dirty="0" err="1"/>
+              <a:t>cứu</a:t>
+            </a:r>
+            <a:r>
+              <a:rPr dirty="0"/>
+              <a:t> </a:t>
+            </a:r>
+            <a:r>
+              <a:rPr dirty="0" err="1"/>
+              <a:t>hộ</a:t>
+            </a:r>
+            <a:r>
+              <a:rPr dirty="0"/>
+              <a:t> </a:t>
+            </a:r>
+            <a:r>
+              <a:rPr dirty="0" err="1"/>
+              <a:t>thiên</a:t>
+            </a:r>
+            <a:r>
+              <a:rPr dirty="0"/>
+              <a:t> tai, </a:t>
+            </a:r>
+            <a:r>
+              <a:rPr dirty="0" err="1"/>
+              <a:t>bão</a:t>
+            </a:r>
+            <a:r>
+              <a:rPr dirty="0"/>
+              <a:t> </a:t>
+            </a:r>
+            <a:r>
+              <a:rPr dirty="0" err="1"/>
+              <a:t>lũ</a:t>
+            </a:r>
+            <a:r>
+              <a:rPr dirty="0"/>
+              <a:t> </a:t>
+            </a:r>
+            <a:r>
+              <a:rPr dirty="0" err="1"/>
+              <a:t>và</a:t>
+            </a:r>
+            <a:r>
+              <a:rPr dirty="0"/>
+              <a:t> </a:t>
+            </a:r>
+            <a:r>
+              <a:rPr dirty="0" err="1"/>
+              <a:t>nông</a:t>
+            </a:r>
+            <a:r>
+              <a:rPr dirty="0"/>
+              <a:t> </a:t>
+            </a:r>
+            <a:r>
+              <a:rPr dirty="0" err="1"/>
+              <a:t>nghiệp</a:t>
+            </a:r>
+            <a:r>
+              <a:rPr dirty="0"/>
+              <a:t>; </a:t>
+            </a:r>
+            <a:r>
+              <a:rPr dirty="0" err="1"/>
+              <a:t>khắc</a:t>
+            </a:r>
+            <a:r>
+              <a:rPr dirty="0"/>
+              <a:t> </a:t>
+            </a:r>
+            <a:r>
+              <a:rPr dirty="0" err="1"/>
+              <a:t>phục</a:t>
+            </a:r>
+            <a:r>
+              <a:rPr dirty="0"/>
+              <a:t> </a:t>
+            </a:r>
+            <a:r>
+              <a:rPr dirty="0" err="1"/>
+              <a:t>triệt</a:t>
+            </a:r>
+            <a:r>
+              <a:rPr dirty="0"/>
+              <a:t> </a:t>
+            </a:r>
+            <a:r>
+              <a:rPr dirty="0" err="1"/>
+              <a:t>để</a:t>
+            </a:r>
+            <a:r>
+              <a:rPr dirty="0"/>
+              <a:t> </a:t>
+            </a:r>
+            <a:r>
+              <a:rPr dirty="0" err="1"/>
+              <a:t>mất</a:t>
+            </a:r>
+            <a:r>
+              <a:rPr dirty="0"/>
+              <a:t> </a:t>
+            </a:r>
+            <a:r>
+              <a:rPr dirty="0" err="1"/>
+              <a:t>dấu</a:t>
+            </a:r>
+            <a:r>
+              <a:rPr dirty="0"/>
+              <a:t> </a:t>
+            </a:r>
+            <a:r>
+              <a:rPr dirty="0" err="1"/>
+              <a:t>và</a:t>
+            </a:r>
+            <a:r>
+              <a:rPr dirty="0"/>
+              <a:t> </a:t>
+            </a:r>
+            <a:r>
+              <a:rPr dirty="0" err="1"/>
+              <a:t>trôi</a:t>
+            </a:r>
+            <a:r>
+              <a:rPr dirty="0"/>
+              <a:t> </a:t>
+            </a:r>
+            <a:r>
+              <a:rPr dirty="0" err="1"/>
+              <a:t>dạt</a:t>
+            </a:r>
+            <a:r>
+              <a:rPr dirty="0"/>
+              <a:t> </a:t>
+            </a:r>
+            <a:r>
+              <a:rPr dirty="0" err="1"/>
+              <a:t>tích</a:t>
+            </a:r>
+            <a:r>
+              <a:rPr dirty="0"/>
+              <a:t> </a:t>
+            </a:r>
+            <a:r>
+              <a:rPr dirty="0" err="1"/>
+              <a:t>lũy</a:t>
+            </a:r>
+            <a:r>
+              <a:rPr dirty="0"/>
+              <a:t> </a:t>
+            </a:r>
+            <a:r>
+              <a:rPr dirty="0" err="1"/>
+              <a:t>mà</a:t>
+            </a:r>
+            <a:r>
+              <a:rPr dirty="0"/>
+              <a:t> </a:t>
+            </a:r>
+            <a:r>
+              <a:rPr dirty="0" err="1"/>
+              <a:t>không</a:t>
+            </a:r>
+            <a:r>
+              <a:rPr dirty="0"/>
+              <a:t> </a:t>
+            </a:r>
+            <a:r>
+              <a:rPr dirty="0" err="1"/>
+              <a:t>ép</a:t>
+            </a:r>
+            <a:r>
+              <a:rPr dirty="0"/>
+              <a:t> </a:t>
+            </a:r>
+            <a:r>
+              <a:rPr dirty="0" err="1"/>
+              <a:t>buộc</a:t>
+            </a:r>
+            <a:r>
+              <a:rPr dirty="0"/>
+              <a:t> GPS RTK </a:t>
+            </a:r>
+            <a:r>
+              <a:rPr dirty="0" err="1"/>
+              <a:t>đắt</a:t>
+            </a:r>
+            <a:r>
+              <a:rPr dirty="0"/>
+              <a:t> </a:t>
+            </a:r>
+            <a:r>
+              <a:rPr dirty="0" err="1"/>
+              <a:t>tiền</a:t>
+            </a:r>
+            <a:r>
+              <a:rPr dirty="0"/>
+              <a:t>.</a:t>
             </a:r>
           </a:p>
           <a:p>
@@ -10437,8 +10929,54 @@
               </a:defRPr>
             </a:pPr>
             <a:r>
-              <a:t>02  Đột phá phương pháp tiếp cận</a:t>
-            </a:r>
+              <a:rPr dirty="0"/>
+              <a:t>02  </a:t>
+            </a:r>
+            <a:r>
+              <a:rPr dirty="0" err="1"/>
+              <a:t>Đột</a:t>
+            </a:r>
+            <a:r>
+              <a:rPr dirty="0"/>
+              <a:t> </a:t>
+            </a:r>
+            <a:r>
+              <a:rPr dirty="0" err="1"/>
+              <a:t>phá</a:t>
+            </a:r>
+            <a:r>
+              <a:rPr dirty="0"/>
+              <a:t> </a:t>
+            </a:r>
+            <a:r>
+              <a:rPr dirty="0" err="1"/>
+              <a:t>phương</a:t>
+            </a:r>
+            <a:r>
+              <a:rPr dirty="0"/>
+              <a:t> </a:t>
+            </a:r>
+            <a:r>
+              <a:rPr dirty="0" err="1"/>
+              <a:t>pháp</a:t>
+            </a:r>
+            <a:r>
+              <a:rPr dirty="0"/>
+              <a:t> </a:t>
+            </a:r>
+            <a:r>
+              <a:rPr dirty="0" err="1"/>
+              <a:t>tiếp</a:t>
+            </a:r>
+            <a:r>
+              <a:rPr dirty="0"/>
+              <a:t> </a:t>
+            </a:r>
+            <a:r>
+              <a:rPr dirty="0" err="1"/>
+              <a:t>cận</a:t>
+            </a:r>
+            <a:endParaRPr dirty="0"/>
           </a:p>
           <a:p>
             <a:pPr>
@@ -10456,7 +10994,232 @@
               </a:defRPr>
             </a:pPr>
             <a:r>
-              <a:t>Khung làm việc 2 tầng kết hợp cảnh báo rủi ro sớm (Risk Gate) và phân luồng thích ứng (Matcher Router) giúp hệ thống vận hành trơn tru ngay trên laptop cá nhân thông thường.</a:t>
+              <a:rPr dirty="0"/>
+              <a:t>Khung </a:t>
+            </a:r>
+            <a:r>
+              <a:rPr dirty="0" err="1"/>
+              <a:t>làm</a:t>
+            </a:r>
+            <a:r>
+              <a:rPr dirty="0"/>
+              <a:t> </a:t>
+            </a:r>
+            <a:r>
+              <a:rPr dirty="0" err="1"/>
+              <a:t>việc</a:t>
+            </a:r>
+            <a:r>
+              <a:rPr dirty="0"/>
+              <a:t> 2 </a:t>
+            </a:r>
+            <a:r>
+              <a:rPr dirty="0" err="1"/>
+              <a:t>tầng</a:t>
+            </a:r>
+            <a:r>
+              <a:rPr dirty="0"/>
+              <a:t> </a:t>
+            </a:r>
+            <a:r>
+              <a:rPr dirty="0" err="1"/>
+              <a:t>kết</a:t>
+            </a:r>
+            <a:r>
+              <a:rPr dirty="0"/>
+              <a:t> </a:t>
+            </a:r>
+            <a:r>
+              <a:rPr dirty="0" err="1"/>
+              <a:t>hợp</a:t>
+            </a:r>
+            <a:r>
+              <a:rPr dirty="0"/>
+              <a:t> </a:t>
+            </a:r>
+            <a:r>
+              <a:rPr dirty="0" err="1"/>
+              <a:t>cảnh</a:t>
+            </a:r>
+            <a:r>
+              <a:rPr dirty="0"/>
+              <a:t> </a:t>
+            </a:r>
+            <a:r>
+              <a:rPr dirty="0" err="1"/>
+              <a:t>báo</a:t>
+            </a:r>
+            <a:r>
+              <a:rPr dirty="0"/>
+              <a:t> </a:t>
+            </a:r>
+            <a:r>
+              <a:rPr dirty="0" err="1"/>
+              <a:t>rủi</a:t>
+            </a:r>
+            <a:r>
+              <a:rPr dirty="0"/>
+              <a:t> </a:t>
+            </a:r>
+            <a:r>
+              <a:rPr dirty="0" err="1"/>
+              <a:t>ro</a:t>
+            </a:r>
+            <a:r>
+              <a:rPr dirty="0"/>
+              <a:t> </a:t>
+            </a:r>
+            <a:r>
+              <a:rPr dirty="0" err="1"/>
+              <a:t>sớm</a:t>
+            </a:r>
+            <a:r>
+              <a:rPr dirty="0"/>
+              <a:t> (Risk Gate) </a:t>
+            </a:r>
+            <a:r>
+              <a:rPr dirty="0" err="1"/>
+              <a:t>và</a:t>
+            </a:r>
+            <a:r>
+              <a:rPr dirty="0"/>
+              <a:t> </a:t>
+            </a:r>
+            <a:r>
+              <a:rPr dirty="0" err="1"/>
+              <a:t>phân</a:t>
+            </a:r>
+            <a:r>
+              <a:rPr dirty="0"/>
+              <a:t> </a:t>
+            </a:r>
+            <a:r>
+              <a:rPr dirty="0" err="1"/>
+              <a:t>luồng</a:t>
+            </a:r>
+            <a:r>
+              <a:rPr dirty="0"/>
+              <a:t> </a:t>
+            </a:r>
+            <a:r>
+              <a:rPr dirty="0" err="1"/>
+              <a:t>thích</a:t>
+            </a:r>
+            <a:r>
+              <a:rPr dirty="0"/>
+              <a:t> </a:t>
+            </a:r>
+            <a:r>
+              <a:rPr dirty="0" err="1"/>
+              <a:t>ứng</a:t>
+            </a:r>
+            <a:r>
+              <a:rPr dirty="0"/>
+              <a:t> (Matcher Router) </a:t>
+            </a:r>
+            <a:r>
+              <a:rPr dirty="0" err="1"/>
+              <a:t>giúp</a:t>
+            </a:r>
+            <a:r>
+              <a:rPr dirty="0"/>
+              <a:t> </a:t>
+            </a:r>
+            <a:r>
+              <a:rPr dirty="0" err="1"/>
+              <a:t>hệ</a:t>
+            </a:r>
+            <a:r>
+              <a:rPr dirty="0"/>
+              <a:t> </a:t>
+            </a:r>
+            <a:r>
+              <a:rPr dirty="0" err="1"/>
+              <a:t>thống</a:t>
+            </a:r>
+            <a:r>
+              <a:rPr dirty="0"/>
+              <a:t> </a:t>
+            </a:r>
+            <a:r>
+              <a:rPr dirty="0" err="1"/>
+              <a:t>vận</a:t>
+            </a:r>
+            <a:r>
+              <a:rPr dirty="0"/>
+              <a:t> </a:t>
+            </a:r>
+            <a:r>
+              <a:rPr dirty="0" err="1"/>
+              <a:t>hành</a:t>
+            </a:r>
+            <a:r>
+              <a:rPr dirty="0"/>
+              <a:t> </a:t>
+            </a:r>
+            <a:r>
+              <a:rPr dirty="0" err="1"/>
+              <a:t>trơn</a:t>
+            </a:r>
+            <a:r>
+              <a:rPr dirty="0"/>
+              <a:t> </a:t>
+            </a:r>
+            <a:r>
+              <a:rPr dirty="0" err="1"/>
+              <a:t>tru</a:t>
+            </a:r>
+            <a:r>
+              <a:rPr dirty="0"/>
+              <a:t> </a:t>
+            </a:r>
+            <a:r>
+              <a:rPr dirty="0" err="1"/>
+              <a:t>ngay</a:t>
+            </a:r>
+            <a:r>
+              <a:rPr dirty="0"/>
+              <a:t> </a:t>
+            </a:r>
+            <a:r>
+              <a:rPr dirty="0" err="1"/>
+              <a:t>trên</a:t>
+            </a:r>
+            <a:r>
+              <a:rPr dirty="0"/>
+              <a:t> laptop </a:t>
+            </a:r>
+            <a:r>
+              <a:rPr dirty="0" err="1"/>
+              <a:t>cá</a:t>
+            </a:r>
+            <a:r>
+              <a:rPr dirty="0"/>
+              <a:t> </a:t>
+            </a:r>
+            <a:r>
+              <a:rPr dirty="0" err="1"/>
+              <a:t>nhân</a:t>
+            </a:r>
+            <a:r>
+              <a:rPr dirty="0"/>
+              <a:t> </a:t>
+            </a:r>
+            <a:r>
+              <a:rPr dirty="0" err="1"/>
+              <a:t>thông</a:t>
+            </a:r>
+            <a:r>
+              <a:rPr dirty="0"/>
+              <a:t> </a:t>
+            </a:r>
+            <a:r>
+              <a:rPr dirty="0" err="1"/>
+              <a:t>thường</a:t>
+            </a:r>
+            <a:r>
+              <a:rPr dirty="0"/>
+              <a:t>.</a:t>
             </a:r>
           </a:p>
           <a:p>
@@ -10475,8 +11238,54 @@
               </a:defRPr>
             </a:pPr>
             <a:r>
-              <a:t>03  Kế hoạch khả thi &amp; sẵn sàng</a:t>
-            </a:r>
+              <a:rPr dirty="0"/>
+              <a:t>03  </a:t>
+            </a:r>
+            <a:r>
+              <a:rPr dirty="0" err="1"/>
+              <a:t>Kế</a:t>
+            </a:r>
+            <a:r>
+              <a:rPr dirty="0"/>
+              <a:t> </a:t>
+            </a:r>
+            <a:r>
+              <a:rPr dirty="0" err="1"/>
+              <a:t>hoạch</a:t>
+            </a:r>
+            <a:r>
+              <a:rPr dirty="0"/>
+              <a:t> </a:t>
+            </a:r>
+            <a:r>
+              <a:rPr dirty="0" err="1"/>
+              <a:t>khả</a:t>
+            </a:r>
+            <a:r>
+              <a:rPr dirty="0"/>
+              <a:t> </a:t>
+            </a:r>
+            <a:r>
+              <a:rPr dirty="0" err="1"/>
+              <a:t>thi</a:t>
+            </a:r>
+            <a:r>
+              <a:rPr dirty="0"/>
+              <a:t> &amp; </a:t>
+            </a:r>
+            <a:r>
+              <a:rPr dirty="0" err="1"/>
+              <a:t>sẵn</a:t>
+            </a:r>
+            <a:r>
+              <a:rPr dirty="0"/>
+              <a:t> </a:t>
+            </a:r>
+            <a:r>
+              <a:rPr dirty="0" err="1"/>
+              <a:t>sàng</a:t>
+            </a:r>
+            <a:endParaRPr dirty="0"/>
           </a:p>
           <a:p>
             <a:pPr>
@@ -10494,7 +11303,228 @@
               </a:defRPr>
             </a:pPr>
             <a:r>
-              <a:t>Dữ liệu UAV thật từ NPU Drone-Map và DroneZaic đã sẵn sàng, 4 thành viên phân công trách nhiệm rõ ràng theo lộ trình 6 tuần cụ thể, cam kết hoàn thành đúng hạn.</a:t>
+              <a:rPr dirty="0" err="1"/>
+              <a:t>Dữ</a:t>
+            </a:r>
+            <a:r>
+              <a:rPr dirty="0"/>
+              <a:t> </a:t>
+            </a:r>
+            <a:r>
+              <a:rPr dirty="0" err="1"/>
+              <a:t>liệu</a:t>
+            </a:r>
+            <a:r>
+              <a:rPr dirty="0"/>
+              <a:t> UAV </a:t>
+            </a:r>
+            <a:r>
+              <a:rPr dirty="0" err="1"/>
+              <a:t>thật</a:t>
+            </a:r>
+            <a:r>
+              <a:rPr dirty="0"/>
+              <a:t> </a:t>
+            </a:r>
+            <a:r>
+              <a:rPr dirty="0" err="1"/>
+              <a:t>từ</a:t>
+            </a:r>
+            <a:r>
+              <a:rPr dirty="0"/>
+              <a:t> NPU Drone-Map </a:t>
+            </a:r>
+            <a:r>
+              <a:rPr dirty="0" err="1"/>
+              <a:t>và</a:t>
+            </a:r>
+            <a:r>
+              <a:rPr dirty="0"/>
+              <a:t> </a:t>
+            </a:r>
+            <a:r>
+              <a:rPr dirty="0" err="1"/>
+              <a:t>DroneZaic</a:t>
+            </a:r>
+            <a:r>
+              <a:rPr dirty="0"/>
+              <a:t> </a:t>
+            </a:r>
+            <a:r>
+              <a:rPr dirty="0" err="1"/>
+              <a:t>đã</a:t>
+            </a:r>
+            <a:r>
+              <a:rPr dirty="0"/>
+              <a:t> </a:t>
+            </a:r>
+            <a:r>
+              <a:rPr dirty="0" err="1"/>
+              <a:t>sẵn</a:t>
+            </a:r>
+            <a:r>
+              <a:rPr dirty="0"/>
+              <a:t> </a:t>
+            </a:r>
+            <a:r>
+              <a:rPr dirty="0" err="1"/>
+              <a:t>sàng</a:t>
+            </a:r>
+            <a:r>
+              <a:rPr dirty="0"/>
+              <a:t>, 4 </a:t>
+            </a:r>
+            <a:r>
+              <a:rPr dirty="0" err="1"/>
+              <a:t>thành</a:t>
+            </a:r>
+            <a:r>
+              <a:rPr dirty="0"/>
+              <a:t> </a:t>
+            </a:r>
+            <a:r>
+              <a:rPr dirty="0" err="1"/>
+              <a:t>viên</a:t>
+            </a:r>
+            <a:r>
+              <a:rPr dirty="0"/>
+              <a:t> </a:t>
+            </a:r>
+            <a:r>
+              <a:rPr dirty="0" err="1"/>
+              <a:t>phân</a:t>
+            </a:r>
+            <a:r>
+              <a:rPr dirty="0"/>
+              <a:t> </a:t>
+            </a:r>
+            <a:r>
+              <a:rPr dirty="0" err="1"/>
+              <a:t>công</a:t>
+            </a:r>
+            <a:r>
+              <a:rPr dirty="0"/>
+              <a:t> </a:t>
+            </a:r>
+            <a:r>
+              <a:rPr dirty="0" err="1"/>
+              <a:t>trách</a:t>
+            </a:r>
+            <a:r>
+              <a:rPr dirty="0"/>
+              <a:t> </a:t>
+            </a:r>
+            <a:r>
+              <a:rPr dirty="0" err="1"/>
+              <a:t>nhiệm</a:t>
+            </a:r>
+            <a:r>
+              <a:rPr dirty="0"/>
+              <a:t> </a:t>
+            </a:r>
+            <a:r>
+              <a:rPr dirty="0" err="1"/>
+              <a:t>rõ</a:t>
+            </a:r>
+            <a:r>
+              <a:rPr dirty="0"/>
+              <a:t> </a:t>
+            </a:r>
+            <a:r>
+              <a:rPr dirty="0" err="1"/>
+              <a:t>ràng</a:t>
+            </a:r>
+            <a:r>
+              <a:rPr dirty="0"/>
+              <a:t> </a:t>
+            </a:r>
+            <a:r>
+              <a:rPr dirty="0" err="1"/>
+              <a:t>theo</a:t>
+            </a:r>
+            <a:r>
+              <a:rPr dirty="0"/>
+              <a:t> </a:t>
+            </a:r>
+            <a:r>
+              <a:rPr dirty="0" err="1"/>
+              <a:t>lộ</a:t>
+            </a:r>
+            <a:r>
+              <a:rPr dirty="0"/>
+              <a:t> </a:t>
+            </a:r>
+            <a:r>
+              <a:rPr dirty="0" err="1"/>
+              <a:t>trình</a:t>
+            </a:r>
+            <a:r>
+              <a:rPr dirty="0"/>
+              <a:t> 6 </a:t>
+            </a:r>
+            <a:r>
+              <a:rPr dirty="0" err="1"/>
+              <a:t>tuần</a:t>
+            </a:r>
+            <a:r>
+              <a:rPr dirty="0"/>
+              <a:t> </a:t>
+            </a:r>
+            <a:r>
+              <a:rPr dirty="0" err="1"/>
+              <a:t>cụ</a:t>
+            </a:r>
+            <a:r>
+              <a:rPr dirty="0"/>
+              <a:t> </a:t>
+            </a:r>
+            <a:r>
+              <a:rPr dirty="0" err="1"/>
+              <a:t>thể</a:t>
+            </a:r>
+            <a:r>
+              <a:rPr dirty="0"/>
+              <a:t>, cam </a:t>
+            </a:r>
+            <a:r>
+              <a:rPr dirty="0" err="1"/>
+              <a:t>kết</a:t>
+            </a:r>
+            <a:r>
+              <a:rPr dirty="0"/>
+              <a:t> </a:t>
+            </a:r>
+            <a:r>
+              <a:rPr dirty="0" err="1"/>
+              <a:t>hoàn</a:t>
+            </a:r>
+            <a:r>
+              <a:rPr dirty="0"/>
+              <a:t> </a:t>
+            </a:r>
+            <a:r>
+              <a:rPr dirty="0" err="1"/>
+              <a:t>thành</a:t>
+            </a:r>
+            <a:r>
+              <a:rPr dirty="0"/>
+              <a:t> </a:t>
+            </a:r>
+            <a:r>
+              <a:rPr dirty="0" err="1"/>
+              <a:t>đúng</a:t>
+            </a:r>
+            <a:r>
+              <a:rPr dirty="0"/>
+              <a:t> </a:t>
+            </a:r>
+            <a:r>
+              <a:rPr dirty="0" err="1"/>
+              <a:t>hạn</a:t>
+            </a:r>
+            <a:r>
+              <a:rPr dirty="0"/>
+              <a:t>.</a:t>
             </a:r>
           </a:p>
         </p:txBody>
@@ -10544,141 +11574,6 @@
               </a:lnSpc>
             </a:pPr>
             <a:endParaRPr/>
-          </a:p>
-        </p:txBody>
-      </p:sp>
-      <p:sp>
-        <p:nvSpPr>
-          <p:cNvPr id="6" name="TextBox 5"/>
-          <p:cNvSpPr txBox="1"/>
-          <p:nvPr/>
-        </p:nvSpPr>
-        <p:spPr>
-          <a:xfrm>
-            <a:off x="731520" y="4069080"/>
-            <a:ext cx="7680960" cy="215444"/>
-          </a:xfrm>
-          <a:prstGeom prst="rect">
-            <a:avLst/>
-          </a:prstGeom>
-          <a:noFill/>
-        </p:spPr>
-        <p:txBody>
-          <a:bodyPr wrap="square" lIns="0" tIns="0" rIns="0" bIns="0">
-            <a:spAutoFit/>
-          </a:bodyPr>
-          <a:lstStyle/>
-          <a:p>
-            <a:pPr>
-              <a:lnSpc>
-                <a:spcPct val="200000"/>
-              </a:lnSpc>
-              <a:spcAft>
-                <a:spcPts val="300"/>
-              </a:spcAft>
-              <a:defRPr sz="1400" b="1">
-                <a:solidFill>
-                  <a:srgbClr val="FFFFFF"/>
-                </a:solidFill>
-                <a:latin typeface="Segoe UI"/>
-              </a:defRPr>
-            </a:pPr>
-            <a:r>
-              <a:rPr dirty="0" err="1"/>
-              <a:t>Nhóm</a:t>
-            </a:r>
-            <a:r>
-              <a:rPr dirty="0"/>
-              <a:t> 09 </a:t>
-            </a:r>
-            <a:r>
-              <a:rPr dirty="0" err="1"/>
-              <a:t>xin</a:t>
-            </a:r>
-            <a:r>
-              <a:rPr dirty="0"/>
-              <a:t> </a:t>
-            </a:r>
-            <a:r>
-              <a:rPr dirty="0" err="1"/>
-              <a:t>chân</a:t>
-            </a:r>
-            <a:r>
-              <a:rPr dirty="0"/>
-              <a:t> </a:t>
-            </a:r>
-            <a:r>
-              <a:rPr dirty="0" err="1"/>
-              <a:t>thành</a:t>
-            </a:r>
-            <a:r>
-              <a:rPr dirty="0"/>
-              <a:t> </a:t>
-            </a:r>
-            <a:r>
-              <a:rPr dirty="0" err="1"/>
-              <a:t>cảm</a:t>
-            </a:r>
-            <a:r>
-              <a:rPr dirty="0"/>
-              <a:t> </a:t>
-            </a:r>
-            <a:r>
-              <a:rPr dirty="0" err="1"/>
-              <a:t>ơn</a:t>
-            </a:r>
-            <a:r>
-              <a:rPr dirty="0"/>
-              <a:t> </a:t>
-            </a:r>
-            <a:r>
-              <a:rPr lang="en-US" dirty="0" err="1"/>
-              <a:t>Thầy</a:t>
-            </a:r>
-            <a:r>
-              <a:rPr lang="en-US" dirty="0"/>
-              <a:t> </a:t>
-            </a:r>
-            <a:r>
-              <a:rPr lang="en-US" dirty="0" err="1"/>
-              <a:t>và</a:t>
-            </a:r>
-            <a:r>
-              <a:rPr lang="en-US" dirty="0"/>
-              <a:t> </a:t>
-            </a:r>
-            <a:r>
-              <a:rPr lang="en-US" dirty="0" err="1"/>
-              <a:t>các</a:t>
-            </a:r>
-            <a:r>
-              <a:rPr lang="en-US" dirty="0"/>
-              <a:t> </a:t>
-            </a:r>
-            <a:r>
-              <a:rPr lang="en-US" dirty="0" err="1"/>
-              <a:t>bạn</a:t>
-            </a:r>
-            <a:r>
-              <a:rPr lang="en-US" dirty="0"/>
-              <a:t> </a:t>
-            </a:r>
-            <a:r>
-              <a:rPr lang="en-US" dirty="0" err="1"/>
-              <a:t>đã</a:t>
-            </a:r>
-            <a:r>
-              <a:rPr lang="en-US" dirty="0"/>
-              <a:t> </a:t>
-            </a:r>
-            <a:r>
-              <a:rPr lang="en-US" dirty="0" err="1"/>
-              <a:t>nghe</a:t>
-            </a:r>
-            <a:r>
-              <a:rPr dirty="0"/>
-              <a:t>!</a:t>
-            </a:r>
           </a:p>
         </p:txBody>
       </p:sp>

</xml_diff>